<commit_message>
Refresh lesson PDF resources and spectrometer explanations
</commit_message>
<xml_diff>
--- a/assets/lessons/lectures/astronomy/planning-observations-2018.pptx
+++ b/assets/lessons/lectures/astronomy/planning-observations-2018.pptx
@@ -36848,7 +36848,7 @@
                 <a:sym typeface="Calibri"/>
                 <a:hlinkClick r:id="rId3"/>
               </a:rPr>
-              <a:t>http://www.iiap.res.in/personnel/reks/software/javascript/calclst.php</a:t>
+              <a:t>https://aa.usno.navy.mil/data/siderealtime</a:t>
             </a:r>
             <a:endParaRPr b="0" i="0" sz="1800" u="none" cap="none" strike="noStrike">
               <a:solidFill>
@@ -36888,7 +36888,7 @@
                 <a:cs typeface="Calibri"/>
                 <a:sym typeface="Calibri"/>
               </a:rPr>
-              <a:t>http://www.wwu.edu/skywise/skymobile/skywatch.html</a:t>
+              <a:t>Enter the date, UT1 time, and longitude.</a:t>
             </a:r>
             <a:endParaRPr b="0" i="0" sz="1800" u="none" cap="none" strike="noStrike">
               <a:solidFill>

</xml_diff>